<commit_message>
Add the Addis-vs-Adama crossplot slide to the Adama summary
Side-by-side crossplots: Addis deployed FTIR EC vs HIPS (fixed 190, the
committed OLS 1.90x-4.17 drawn, Deming lambda* 2.24x-5.86 in the stat box)
next to Adama FTIR EC vs collocated quartz TOR (five date-matched pairs,
median ratio 0.77, points and 1:1 only; no line is fitted at n=5 because
one high-leverage filter makes any fit meaningless). The geometry contrast,
tight systematic line versus unstructured scatter, is the claim. Deck is
now 4 slides, no em dashes, SAY/NOTES verified.

Co-Authored-By: Claude Fable 5 <noreply@anthropic.com>
</commit_message>
<xml_diff>
--- a/deliverables/adama_summary_2026-08-25/adama_summary_2026-08-25.pptx
+++ b/deliverables/adama_summary_2026-08-25/adama_summary_2026-08-25.pptx
@@ -8,6 +8,7 @@
     <p:sldId id="256" r:id="rId7"/>
     <p:sldId id="257" r:id="rId9"/>
     <p:sldId id="258" r:id="rId10"/>
+    <p:sldId id="259" r:id="rId11"/>
   </p:sldIdLst>
   <p:sldSz cx="12191695" cy="6858000" type="screen4x3"/>
   <p:notesSz cx="6858000" cy="9144000"/>
@@ -580,13 +581,13 @@
           <a:lstStyle/>
           <a:p>
             <a:r>
-              <a:t>SAY: The comparison Ann asked about, from the five co-located PTFE and quartz pairs. Left: FTIR EC over TOR EC per filter. The production calibration scatters around one with a median of 0.77; there is no systematic factor-of-two gap like the Addis crossplot, though five filters is five filters. The biomass-trained calibrations over-read by about one and a half times, which is a calibration-choice effect, not an Adama anomaly. Right: the thermal char-to-soot split. Every filter is soot-dominated; nothing here looks like a charcoal-heavy aerosol either.</a:t>
+              <a:t>SAY: The two crossplots next to each other. Left: Addis, the deployed FTIR EC against HIPS on the fixed 190 filters; a tight line at 1.90x with an intercept of minus 4.2, the systematic disagreement this whole program is about. Right: Adama, the same production calibration against collocated quartz TOR; five filters scattering around the one-to-one line, median ratio 0.77, with no line fitted because five points cannot support one. Different reference method, and a completely different picture: a tight systematic line on the left, unstructured scatter on the right.</a:t>
             </a:r>
           </a:p>
           <a:p/>
           <a:p>
             <a:r>
-              <a:t>NOTES: Pairs matched by sample date (PTFE J1233-J1285 vs quartz J1675-J1703), July 2024 only, n=5. Ratios are unitless so the loading-vs-concentration units question drops out. char/soot = (EC1-OP)/(EC2+EC3), Han convention; all values 0.02 to 0.58, char-dominated would be above 1. Committed table: spartan_ec_2026_06_16/tables/adama_ec_calibration_comparison.csv.</a:t>
+              <a:t>NOTES: Axes differ by construction: Addis is ug/m3 against HIPS Fabs/10 (MAC 10); Adama is ug per filter against TOR ECTR, pairs matched by sample date (no HIPS exists for Adama PTFE, and no quartz exists at Addis; that asymmetry is the point of the quartz-TOR ask). The drawn Addis line is OLS, reproducing the committed ftir_17 number 1.90x-4.17; Deming at lambda-star reads steeper (2.24x-5.86) and both are in the stat box. Adama OLS on n=5 is descriptive only. The geometry comparison, line versus scatter, is the claim; the fit numbers are context.</a:t>
             </a:r>
           </a:p>
         </p:txBody>
@@ -612,6 +613,82 @@
 </file>
 
 <file path=ppt/notesSlides/notesSlide3.xml><?xml version="1.0" encoding="utf-8"?>
+<p:notes xmlns:a="http://schemas.openxmlformats.org/drawingml/2006/main" xmlns:p="http://schemas.openxmlformats.org/presentationml/2006/main" xmlns:r="http://schemas.openxmlformats.org/officeDocument/2006/relationships">
+  <p:cSld>
+    <p:spTree>
+      <p:nvGrpSpPr>
+        <p:cNvPr id="1" name=""/>
+        <p:cNvGrpSpPr/>
+        <p:nvPr/>
+      </p:nvGrpSpPr>
+      <p:grpSpPr>
+        <a:xfrm>
+          <a:off x="0" y="0"/>
+          <a:ext cx="0" cy="0"/>
+          <a:chOff x="0" y="0"/>
+          <a:chExt cx="0" cy="0"/>
+        </a:xfrm>
+      </p:grpSpPr>
+      <p:sp>
+        <p:nvSpPr>
+          <p:cNvPr id="2" name="Slide Image Placeholder 1"/>
+          <p:cNvSpPr>
+            <a:spLocks noGrp="1"/>
+          </p:cNvSpPr>
+          <p:nvPr>
+            <p:ph type="sldImg" idx="2"/>
+          </p:nvPr>
+        </p:nvSpPr>
+        <p:spPr/>
+      </p:sp>
+      <p:sp>
+        <p:nvSpPr>
+          <p:cNvPr id="3" name="Notes Placeholder 2"/>
+          <p:cNvSpPr>
+            <a:spLocks noGrp="1"/>
+          </p:cNvSpPr>
+          <p:nvPr>
+            <p:ph type="body" idx="3" sz="quarter"/>
+          </p:nvPr>
+        </p:nvSpPr>
+        <p:spPr/>
+        <p:txBody>
+          <a:bodyPr/>
+          <a:lstStyle/>
+          <a:p>
+            <a:r>
+              <a:t>SAY: The comparison Ann asked about, from the five co-located PTFE and quartz pairs. Left: FTIR EC over TOR EC per filter. The production calibration scatters around one with a median of 0.77; there is no systematic factor-of-two gap like the Addis crossplot, though five filters is five filters. The biomass-trained calibrations over-read by about one and a half times, which is a calibration-choice effect, not an Adama anomaly. Right: the thermal char-to-soot split. Every filter is soot-dominated; nothing here looks like a charcoal-heavy aerosol either.</a:t>
+            </a:r>
+          </a:p>
+          <a:p/>
+          <a:p>
+            <a:r>
+              <a:t>NOTES: Pairs matched by sample date (PTFE J1233-J1285 vs quartz J1675-J1703), July 2024 only, n=5. Ratios are unitless so the loading-vs-concentration units question drops out. char/soot = (EC1-OP)/(EC2+EC3), Han convention; all values 0.02 to 0.58, char-dominated would be above 1. Committed table: spartan_ec_2026_06_16/tables/adama_ec_calibration_comparison.csv.</a:t>
+            </a:r>
+          </a:p>
+        </p:txBody>
+      </p:sp>
+      <p:sp>
+        <p:nvSpPr>
+          <p:cNvPr id="4" name="Slide Number Placeholder 3"/>
+          <p:cNvSpPr>
+            <a:spLocks noGrp="1"/>
+          </p:cNvSpPr>
+          <p:nvPr>
+            <p:ph type="sldNum" idx="5" sz="quarter"/>
+          </p:nvPr>
+        </p:nvSpPr>
+        <p:spPr/>
+      </p:sp>
+    </p:spTree>
+  </p:cSld>
+  <p:clrMapOvr>
+    <a:masterClrMapping/>
+  </p:clrMapOvr>
+</p:notes>
+</file>
+
+<file path=ppt/notesSlides/notesSlide4.xml><?xml version="1.0" encoding="utf-8"?>
 <p:notes xmlns:a="http://schemas.openxmlformats.org/drawingml/2006/main" xmlns:p="http://schemas.openxmlformats.org/presentationml/2006/main" xmlns:r="http://schemas.openxmlformats.org/officeDocument/2006/relationships">
   <p:cSld>
     <p:spTree>
@@ -3775,6 +3852,83 @@
               </a:defRPr>
             </a:pPr>
             <a:r>
+              <a:t>Side by side: the Addis crossplot is a systematic line; the Adama one scatters around 1:1</a:t>
+            </a:r>
+          </a:p>
+        </p:txBody>
+      </p:sp>
+      <p:pic>
+        <p:nvPicPr>
+          <p:cNvPr id="3" name="Picture 2" descr="f_adama_addis_crossplots.png"/>
+          <p:cNvPicPr>
+            <a:picLocks noChangeAspect="1"/>
+          </p:cNvPicPr>
+          <p:nvPr/>
+        </p:nvPicPr>
+        <p:blipFill>
+          <a:blip r:embed="rId2"/>
+          <a:stretch>
+            <a:fillRect/>
+          </a:stretch>
+        </p:blipFill>
+        <p:spPr>
+          <a:xfrm>
+            <a:off x="518007" y="1209423"/>
+            <a:ext cx="11155680" cy="5262113"/>
+          </a:xfrm>
+          <a:prstGeom prst="rect">
+            <a:avLst/>
+          </a:prstGeom>
+        </p:spPr>
+      </p:pic>
+    </p:spTree>
+  </p:cSld>
+  <p:clrMapOvr>
+    <a:masterClrMapping/>
+  </p:clrMapOvr>
+</p:sld>
+</file>
+
+<file path=ppt/slides/slide3.xml><?xml version="1.0" encoding="utf-8"?>
+<p:sld xmlns:a="http://schemas.openxmlformats.org/drawingml/2006/main" xmlns:p="http://schemas.openxmlformats.org/presentationml/2006/main" xmlns:r="http://schemas.openxmlformats.org/officeDocument/2006/relationships">
+  <p:cSld>
+    <p:spTree>
+      <p:nvGrpSpPr>
+        <p:cNvPr id="1" name=""/>
+        <p:cNvGrpSpPr/>
+        <p:nvPr/>
+      </p:nvGrpSpPr>
+      <p:grpSpPr/>
+      <p:sp>
+        <p:nvSpPr>
+          <p:cNvPr id="2" name="TextBox 1"/>
+          <p:cNvSpPr txBox="1"/>
+          <p:nvPr/>
+        </p:nvSpPr>
+        <p:spPr>
+          <a:xfrm>
+            <a:off x="411480" y="201168"/>
+            <a:ext cx="11430000" cy="868680"/>
+          </a:xfrm>
+          <a:prstGeom prst="rect">
+            <a:avLst/>
+          </a:prstGeom>
+          <a:noFill/>
+        </p:spPr>
+        <p:txBody>
+          <a:bodyPr wrap="square">
+            <a:spAutoFit/>
+          </a:bodyPr>
+          <a:lstStyle/>
+          <a:p>
+            <a:pPr>
+              <a:defRPr sz="2000" b="1">
+                <a:solidFill>
+                  <a:srgbClr val="22252A"/>
+                </a:solidFill>
+              </a:defRPr>
+            </a:pPr>
+            <a:r>
               <a:t>At Adama, FTIR EC agrees with quartz TOR; the Addis-style gap is absent</a:t>
             </a:r>
           </a:p>
@@ -3812,7 +3966,7 @@
 </p:sld>
 </file>
 
-<file path=ppt/slides/slide3.xml><?xml version="1.0" encoding="utf-8"?>
+<file path=ppt/slides/slide4.xml><?xml version="1.0" encoding="utf-8"?>
 <p:sld xmlns:a="http://schemas.openxmlformats.org/drawingml/2006/main" xmlns:p="http://schemas.openxmlformats.org/presentationml/2006/main" xmlns:r="http://schemas.openxmlformats.org/officeDocument/2006/relationships">
   <p:cSld>
     <p:spTree>

</xml_diff>

<commit_message>
Fold the ongoing Bishoftu collection into the Adama summary's message slide
Census from the DB export + HIPS batch file: 63 PM2.5 filters through May
2026, 48 scanned, 26 evaluated (one dry season, lot 251, no offset). The
two cheap asks are now on the slide: HIPS for the 22 already-scanned
filters (the 14 dated ones are a second dry season, Jan-Feb 2026) and FTIR
scans for the collected-but-unscanned Belg batch. Notes correct the earlier
belief that Belg filters were in the scanned backlog; they are not scanned
yet.

Co-Authored-By: Claude Fable 5 <noreply@anthropic.com>
</commit_message>
<xml_diff>
--- a/deliverables/adama_summary_2026-08-25/adama_summary_2026-08-25.pptx
+++ b/deliverables/adama_summary_2026-08-25/adama_summary_2026-08-25.pptx
@@ -733,13 +733,13 @@
           <a:lstStyle/>
           <a:p>
             <a:r>
-              <a:t>SAY: The message for Christian and Sina in one line: the five filters we have already show Adama is a different problem from Addis, so more Adama Teflon will not help the Addis question. What would help, from anywhere in the region, is quartz: TOR EC is the measurement all three of our open forks terminate at. If sampling continues at Adama, pairing every Teflon with a quartz punch turns it into exactly that.</a:t>
+              <a:t>SAY: The message for Christian and Sina in one line: the five filters we have already show Adama is a different problem from Addis, so more Adama Teflon will not help the Addis question. What would help, from anywhere in the region, is quartz: TOR EC is the measurement all three of our open forks terminate at. And Bishoftu, which is still collecting, is the ongoing regional control: its no-offset result rests on one dry season, and two cheap lab steps, HIPS on the twenty-two filters already scanned and scans for the Belg batch, would turn it into a two-dry-season, multi-season series.</a:t>
             </a:r>
           </a:p>
           <a:p/>
           <a:p>
             <a:r>
-              <a:t>NOTES: Caveats to volunteer: n=5, one month (July 2024, wet season), so a dry-season Adama surprise is not excluded; the FTIR-vs-TOR agreement is production-calibration specific. The quartz-TOR campaign one-pager (ftir_ec_phase3/quartz_tor_campaign_onepager.md) carries the sizing: about 3 sigma per day separation of MAC 6 vs 10 needs 11 to 13 days per season, three seasons.</a:t>
+              <a:t>NOTES: Bishoftu census from the 2026-08-22 DB export plus the HIPS batch file: 63 PM2.5 filters dated 2025-10-20 to 2026-05-19, 48 scanned, 26 with Fabs (all lot 251, dry season). Of the 22 scanned-awaiting-HIPS, the 14 dated ones are 2026-01-17 to 2026-02-19 (second dry season); 8 lack dates in the export. The Belg filters are collected but not yet FTIR-scanned; correct the earlier note that Belg filters were among the scanned backlog. Caveats to volunteer: n=5, one month (July 2024, wet season), so a dry-season Adama surprise is not excluded; the FTIR-vs-TOR agreement is production-calibration specific. The quartz-TOR campaign one-pager (ftir_ec_phase3/quartz_tor_campaign_onepager.md) carries the sizing: about 3 sigma per day separation of MAC 6 vs 10 needs 11 to 13 days per season, three seasons.</a:t>
             </a:r>
           </a:p>
         </p:txBody>
@@ -4074,7 +4074,7 @@
               </a:defRPr>
             </a:pPr>
             <a:r>
-              <a:t>The binding constraint on the Addis question is an independent EC measurement</a:t>
+              <a:t>The binding constraint is an independent EC measurement at Addis itself:</a:t>
             </a:r>
           </a:p>
           <a:p>
@@ -4089,7 +4089,7 @@
               </a:defRPr>
             </a:pPr>
             <a:r>
-              <a:t>   at Addis itself: the quartz TOR campaign (about 36 filters across 3 seasons)</a:t>
+              <a:t>   the quartz TOR campaign (about 36 filters across 3 seasons)</a:t>
             </a:r>
           </a:p>
           <a:p>
@@ -4104,7 +4104,7 @@
               </a:defRPr>
             </a:pPr>
             <a:r>
-              <a:t>If Adama sampling continues anyway: co-located quartz alongside the Teflon would make</a:t>
+              <a:t>If Adama sampling continues: co-located quartz would make every future pair a TOR anchor</a:t>
             </a:r>
           </a:p>
           <a:p>
@@ -4119,7 +4119,52 @@
               </a:defRPr>
             </a:pPr>
             <a:r>
-              <a:t>   every future pair a TOR anchor, which is the one thing this region can add</a:t>
+              <a:t>Bishoftu is the region's other live stream and it keeps collecting: 63 filters through</a:t>
+            </a:r>
+          </a:p>
+          <a:p>
+            <a:pPr>
+              <a:spcAft>
+                <a:spcPts val="1000"/>
+              </a:spcAft>
+              <a:defRPr sz="1700">
+                <a:solidFill>
+                  <a:srgbClr val="22252A"/>
+                </a:solidFill>
+              </a:defRPr>
+            </a:pPr>
+            <a:r>
+              <a:t>   May 2026; 26 evaluated so far (one dry season, no offset). Two cheap asks: run HIPS</a:t>
+            </a:r>
+          </a:p>
+          <a:p>
+            <a:pPr>
+              <a:spcAft>
+                <a:spcPts val="1000"/>
+              </a:spcAft>
+              <a:defRPr sz="1700">
+                <a:solidFill>
+                  <a:srgbClr val="22252A"/>
+                </a:solidFill>
+              </a:defRPr>
+            </a:pPr>
+            <a:r>
+              <a:t>   on the 22 already-scanned filters (14 are a second dry season, Jan to Feb 2026),</a:t>
+            </a:r>
+          </a:p>
+          <a:p>
+            <a:pPr>
+              <a:spcAft>
+                <a:spcPts val="1000"/>
+              </a:spcAft>
+              <a:defRPr sz="1700">
+                <a:solidFill>
+                  <a:srgbClr val="22252A"/>
+                </a:solidFill>
+              </a:defRPr>
+            </a:pPr>
+            <a:r>
+              <a:t>   and scan the Belg-season batch; each lands in the evaluation with one command</a:t>
             </a:r>
           </a:p>
         </p:txBody>

</xml_diff>

<commit_message>
Place the Ethiopian sites inside the IMPROVE network: the three-ratio slide
The June fig08 pair (OC/EC and OC/fAbs by site) finally built, from
local_db per-site-day medians (199 IMPROVE sites, 100+ days each) with the
SPARTAN sites placed as percentile markers, plus a third panel, fAbs per
PM2.5 mass, the axis Bishoftu can join today (Fabs + gravimetric mass, no
OC needed). Result: Addis is the low extreme on OC/EC and OC/fAbs, and
BOTH Ethiopian sites exceed every IMPROVE site on absorption per mass
(Bishoftu 1.6, Addis 2.2 vs IMPROVE max ~1.2) while only Addis carries the
offset: dark aerosol alone does not produce the discrepancy. Fixes en
route: ChemSpec_Filter_PM2.5_mass parameter name and the base-vs-suffixed
FilterId join. Deck is now 5 slides.

Co-Authored-By: Claude Fable 5 <noreply@anthropic.com>
</commit_message>
<xml_diff>
--- a/deliverables/adama_summary_2026-08-25/adama_summary_2026-08-25.pptx
+++ b/deliverables/adama_summary_2026-08-25/adama_summary_2026-08-25.pptx
@@ -9,6 +9,7 @@
     <p:sldId id="257" r:id="rId9"/>
     <p:sldId id="258" r:id="rId10"/>
     <p:sldId id="259" r:id="rId11"/>
+    <p:sldId id="260" r:id="rId12"/>
   </p:sldIdLst>
   <p:sldSz cx="12191695" cy="6858000" type="screen4x3"/>
   <p:notesSz cx="6858000" cy="9144000"/>
@@ -581,13 +582,13 @@
           <a:lstStyle/>
           <a:p>
             <a:r>
-              <a:t>SAY: The two crossplots next to each other. Left: Addis, the deployed FTIR EC against HIPS on the fixed 190 filters; a tight line at 1.90x with an intercept of minus 4.2, the systematic disagreement this whole program is about. Right: Adama, the same production calibration against collocated quartz TOR; five filters scattering around the one-to-one line, median ratio 0.77, with no line fitted because five points cannot support one. Different reference method, and a completely different picture: a tight systematic line on the left, unstructured scatter on the right.</a:t>
+              <a:t>SAY: Where the Ethiopian sites fall inside the IMPROVE network, per-site medians shown as percentiles. Left, OC to EC: Addis sits at the very bottom of the distribution, the suspect low-OC/EC signature, with Delhi for company. Middle, OC per unit absorption: Addis is again the extreme low end, absorption-rich relative to its organics. Right, the panel Bishoftu can join today, absorption per PM mass: Beijing and Pasadena sit at the IMPROVE ninetieth percentile, Delhi at the edge, and BOTH Ethiopian sites are beyond every IMPROVE site, Bishoftu at 1.6 and Addis at 2.2. The kicker: Bishoftu is nearly as absorption-rich per mass as Addis and shows no offset. Dark aerosol alone does not produce the discrepancy; whatever does is specific to Addis.</a:t>
             </a:r>
           </a:p>
           <a:p/>
           <a:p>
             <a:r>
-              <a:t>NOTES: Axes differ by construction: Addis is ug/m3 against HIPS Fabs/10 (MAC 10); Adama is ug per filter against TOR ECTR, pairs matched by sample date (no HIPS exists for Adama PTFE, and no quartz exists at Addis; that asymmetry is the point of the quartz-TOR ask). The drawn Addis line is OLS, reproducing the committed ftir_17 number 1.90x-4.17; Deming at lambda-star reads steeper (2.24x-5.86) and both are in the stat box. Adama OLS on n=5 is descriptive only. The geometry comparison, line versus scatter, is the claim; the fit numbers are context.</a:t>
+              <a:t>NOTES: IMPROVE medians from local_db per site-day (TOR OC/EC in ng/m3 converted, fAbs Mm-1, grav PM2.5), sites with 100+ days only. SPARTAN points use the deployed FTIR OC/EC products and HIPS Fabs from the unified dataset; method mix (TOR vs FTIR OC) is labeled on the axis and is the standing caveat for panel one. Bishoftu appears only in the mass panel: it has Fabs and gravimetric mass but no OC yet; deployed OC/EC for ETBI awaits an analysis.Results pull on the VPN machine. Addis OC/EC and OC/fAbs being lowest is the June fig08 pair result, now reproduced with Bishoftu placed. Circularity note: SPARTAN OC/EC here are FTIR products, so the Addis OC/EC position partly reflects the calibration question itself; the mass panel is calibration-free.</a:t>
             </a:r>
           </a:p>
         </p:txBody>
@@ -657,13 +658,13 @@
           <a:lstStyle/>
           <a:p>
             <a:r>
-              <a:t>SAY: The comparison Ann asked about, from the five co-located PTFE and quartz pairs. Left: FTIR EC over TOR EC per filter. The production calibration scatters around one with a median of 0.77; there is no systematic factor-of-two gap like the Addis crossplot, though five filters is five filters. The biomass-trained calibrations over-read by about one and a half times, which is a calibration-choice effect, not an Adama anomaly. Right: the thermal char-to-soot split. Every filter is soot-dominated; nothing here looks like a charcoal-heavy aerosol either.</a:t>
+              <a:t>SAY: The two crossplots next to each other. Left: Addis, the deployed FTIR EC against HIPS on the fixed 190 filters; a tight line at 1.90x with an intercept of minus 4.2, the systematic disagreement this whole program is about. Right: Adama, the same production calibration against collocated quartz TOR; five filters scattering around the one-to-one line, median ratio 0.77, with no line fitted because five points cannot support one. Different reference method, and a completely different picture: a tight systematic line on the left, unstructured scatter on the right.</a:t>
             </a:r>
           </a:p>
           <a:p/>
           <a:p>
             <a:r>
-              <a:t>NOTES: Pairs matched by sample date (PTFE J1233-J1285 vs quartz J1675-J1703), July 2024 only, n=5. Ratios are unitless so the loading-vs-concentration units question drops out. char/soot = (EC1-OP)/(EC2+EC3), Han convention; all values 0.02 to 0.58, char-dominated would be above 1. Committed table: spartan_ec_2026_06_16/tables/adama_ec_calibration_comparison.csv.</a:t>
+              <a:t>NOTES: Axes differ by construction: Addis is ug/m3 against HIPS Fabs/10 (MAC 10); Adama is ug per filter against TOR ECTR, pairs matched by sample date (no HIPS exists for Adama PTFE, and no quartz exists at Addis; that asymmetry is the point of the quartz-TOR ask). The drawn Addis line is OLS, reproducing the committed ftir_17 number 1.90x-4.17; Deming at lambda-star reads steeper (2.24x-5.86) and both are in the stat box. Adama OLS on n=5 is descriptive only. The geometry comparison, line versus scatter, is the claim; the fit numbers are context.</a:t>
             </a:r>
           </a:p>
         </p:txBody>
@@ -689,6 +690,82 @@
 </file>
 
 <file path=ppt/notesSlides/notesSlide4.xml><?xml version="1.0" encoding="utf-8"?>
+<p:notes xmlns:a="http://schemas.openxmlformats.org/drawingml/2006/main" xmlns:p="http://schemas.openxmlformats.org/presentationml/2006/main" xmlns:r="http://schemas.openxmlformats.org/officeDocument/2006/relationships">
+  <p:cSld>
+    <p:spTree>
+      <p:nvGrpSpPr>
+        <p:cNvPr id="1" name=""/>
+        <p:cNvGrpSpPr/>
+        <p:nvPr/>
+      </p:nvGrpSpPr>
+      <p:grpSpPr>
+        <a:xfrm>
+          <a:off x="0" y="0"/>
+          <a:ext cx="0" cy="0"/>
+          <a:chOff x="0" y="0"/>
+          <a:chExt cx="0" cy="0"/>
+        </a:xfrm>
+      </p:grpSpPr>
+      <p:sp>
+        <p:nvSpPr>
+          <p:cNvPr id="2" name="Slide Image Placeholder 1"/>
+          <p:cNvSpPr>
+            <a:spLocks noGrp="1"/>
+          </p:cNvSpPr>
+          <p:nvPr>
+            <p:ph type="sldImg" idx="2"/>
+          </p:nvPr>
+        </p:nvSpPr>
+        <p:spPr/>
+      </p:sp>
+      <p:sp>
+        <p:nvSpPr>
+          <p:cNvPr id="3" name="Notes Placeholder 2"/>
+          <p:cNvSpPr>
+            <a:spLocks noGrp="1"/>
+          </p:cNvSpPr>
+          <p:nvPr>
+            <p:ph type="body" idx="3" sz="quarter"/>
+          </p:nvPr>
+        </p:nvSpPr>
+        <p:spPr/>
+        <p:txBody>
+          <a:bodyPr/>
+          <a:lstStyle/>
+          <a:p>
+            <a:r>
+              <a:t>SAY: The comparison Ann asked about, from the five co-located PTFE and quartz pairs. Left: FTIR EC over TOR EC per filter. The production calibration scatters around one with a median of 0.77; there is no systematic factor-of-two gap like the Addis crossplot, though five filters is five filters. The biomass-trained calibrations over-read by about one and a half times, which is a calibration-choice effect, not an Adama anomaly. Right: the thermal char-to-soot split. Every filter is soot-dominated; nothing here looks like a charcoal-heavy aerosol either.</a:t>
+            </a:r>
+          </a:p>
+          <a:p/>
+          <a:p>
+            <a:r>
+              <a:t>NOTES: Pairs matched by sample date (PTFE J1233-J1285 vs quartz J1675-J1703), July 2024 only, n=5. Ratios are unitless so the loading-vs-concentration units question drops out. char/soot = (EC1-OP)/(EC2+EC3), Han convention; all values 0.02 to 0.58, char-dominated would be above 1. Committed table: spartan_ec_2026_06_16/tables/adama_ec_calibration_comparison.csv.</a:t>
+            </a:r>
+          </a:p>
+        </p:txBody>
+      </p:sp>
+      <p:sp>
+        <p:nvSpPr>
+          <p:cNvPr id="4" name="Slide Number Placeholder 3"/>
+          <p:cNvSpPr>
+            <a:spLocks noGrp="1"/>
+          </p:cNvSpPr>
+          <p:nvPr>
+            <p:ph type="sldNum" idx="5" sz="quarter"/>
+          </p:nvPr>
+        </p:nvSpPr>
+        <p:spPr/>
+      </p:sp>
+    </p:spTree>
+  </p:cSld>
+  <p:clrMapOvr>
+    <a:masterClrMapping/>
+  </p:clrMapOvr>
+</p:notes>
+</file>
+
+<file path=ppt/notesSlides/notesSlide5.xml><?xml version="1.0" encoding="utf-8"?>
 <p:notes xmlns:a="http://schemas.openxmlformats.org/drawingml/2006/main" xmlns:p="http://schemas.openxmlformats.org/presentationml/2006/main" xmlns:r="http://schemas.openxmlformats.org/officeDocument/2006/relationships">
   <p:cSld>
     <p:spTree>
@@ -3852,6 +3929,83 @@
               </a:defRPr>
             </a:pPr>
             <a:r>
+              <a:t>Both Ethiopian sites are absorption-rich beyond all of IMPROVE, yet only Addis has the offset</a:t>
+            </a:r>
+          </a:p>
+        </p:txBody>
+      </p:sp>
+      <p:pic>
+        <p:nvPicPr>
+          <p:cNvPr id="3" name="Picture 2" descr="f_sites_context_ratios.png"/>
+          <p:cNvPicPr>
+            <a:picLocks noChangeAspect="1"/>
+          </p:cNvPicPr>
+          <p:nvPr/>
+        </p:nvPicPr>
+        <p:blipFill>
+          <a:blip r:embed="rId2"/>
+          <a:stretch>
+            <a:fillRect/>
+          </a:stretch>
+        </p:blipFill>
+        <p:spPr>
+          <a:xfrm>
+            <a:off x="518007" y="1774007"/>
+            <a:ext cx="11155680" cy="4132945"/>
+          </a:xfrm>
+          <a:prstGeom prst="rect">
+            <a:avLst/>
+          </a:prstGeom>
+        </p:spPr>
+      </p:pic>
+    </p:spTree>
+  </p:cSld>
+  <p:clrMapOvr>
+    <a:masterClrMapping/>
+  </p:clrMapOvr>
+</p:sld>
+</file>
+
+<file path=ppt/slides/slide3.xml><?xml version="1.0" encoding="utf-8"?>
+<p:sld xmlns:a="http://schemas.openxmlformats.org/drawingml/2006/main" xmlns:p="http://schemas.openxmlformats.org/presentationml/2006/main" xmlns:r="http://schemas.openxmlformats.org/officeDocument/2006/relationships">
+  <p:cSld>
+    <p:spTree>
+      <p:nvGrpSpPr>
+        <p:cNvPr id="1" name=""/>
+        <p:cNvGrpSpPr/>
+        <p:nvPr/>
+      </p:nvGrpSpPr>
+      <p:grpSpPr/>
+      <p:sp>
+        <p:nvSpPr>
+          <p:cNvPr id="2" name="TextBox 1"/>
+          <p:cNvSpPr txBox="1"/>
+          <p:nvPr/>
+        </p:nvSpPr>
+        <p:spPr>
+          <a:xfrm>
+            <a:off x="411480" y="201168"/>
+            <a:ext cx="11430000" cy="868680"/>
+          </a:xfrm>
+          <a:prstGeom prst="rect">
+            <a:avLst/>
+          </a:prstGeom>
+          <a:noFill/>
+        </p:spPr>
+        <p:txBody>
+          <a:bodyPr wrap="square">
+            <a:spAutoFit/>
+          </a:bodyPr>
+          <a:lstStyle/>
+          <a:p>
+            <a:pPr>
+              <a:defRPr sz="2000" b="1">
+                <a:solidFill>
+                  <a:srgbClr val="22252A"/>
+                </a:solidFill>
+              </a:defRPr>
+            </a:pPr>
+            <a:r>
               <a:t>Side by side: the Addis crossplot is a systematic line; the Adama one scatters around 1:1</a:t>
             </a:r>
           </a:p>
@@ -3889,7 +4043,7 @@
 </p:sld>
 </file>
 
-<file path=ppt/slides/slide3.xml><?xml version="1.0" encoding="utf-8"?>
+<file path=ppt/slides/slide4.xml><?xml version="1.0" encoding="utf-8"?>
 <p:sld xmlns:a="http://schemas.openxmlformats.org/drawingml/2006/main" xmlns:p="http://schemas.openxmlformats.org/presentationml/2006/main" xmlns:r="http://schemas.openxmlformats.org/officeDocument/2006/relationships">
   <p:cSld>
     <p:spTree>
@@ -3966,7 +4120,7 @@
 </p:sld>
 </file>
 
-<file path=ppt/slides/slide4.xml><?xml version="1.0" encoding="utf-8"?>
+<file path=ppt/slides/slide5.xml><?xml version="1.0" encoding="utf-8"?>
 <p:sld xmlns:a="http://schemas.openxmlformats.org/drawingml/2006/main" xmlns:p="http://schemas.openxmlformats.org/presentationml/2006/main" xmlns:r="http://schemas.openxmlformats.org/officeDocument/2006/relationships">
   <p:cSld>
     <p:spTree>

</xml_diff>

<commit_message>
Split the IMPROVE-placement figure into three readable strips, all sites placed
One full-width strip per ratio, each with the 199-site IMPROVE cloud and
every site that has data for that axis as a labeled dot with its percentile:
OC/EC gains Adama (TOR basis, 65th percentile, ordinary) while Addis is
lowest of all; OC/fAbs shows Addis lowest in either network; fAbs/PM2.5 is
the calibration-free axis where both Ethiopian sites exceed all of IMPROVE
yet only Addis carries the offset. Sites that cannot appear are named on
the panel with the reason (Bishoftu: no OC of any kind yet; Adama: no HIPS
on quartz). Deck is now 7 slides.

Co-Authored-By: Claude Fable 5 <noreply@anthropic.com>
</commit_message>
<xml_diff>
--- a/deliverables/adama_summary_2026-08-25/adama_summary_2026-08-25.pptx
+++ b/deliverables/adama_summary_2026-08-25/adama_summary_2026-08-25.pptx
@@ -10,6 +10,8 @@
     <p:sldId id="258" r:id="rId10"/>
     <p:sldId id="259" r:id="rId11"/>
     <p:sldId id="260" r:id="rId12"/>
+    <p:sldId id="261" r:id="rId13"/>
+    <p:sldId id="262" r:id="rId14"/>
   </p:sldIdLst>
   <p:sldSz cx="12191695" cy="6858000" type="screen4x3"/>
   <p:notesSz cx="6858000" cy="9144000"/>
@@ -582,13 +584,13 @@
           <a:lstStyle/>
           <a:p>
             <a:r>
-              <a:t>SAY: Where the Ethiopian sites fall inside the IMPROVE network, per-site medians shown as percentiles. Left, OC to EC: Addis sits at the very bottom of the distribution, the suspect low-OC/EC signature, with Delhi for company. Middle, OC per unit absorption: Addis is again the extreme low end, absorption-rich relative to its organics. Right, the panel Bishoftu can join today, absorption per PM mass: Beijing and Pasadena sit at the IMPROVE ninetieth percentile, Delhi at the edge, and BOTH Ethiopian sites are beyond every IMPROVE site, Bishoftu at 1.6 and Addis at 2.2. The kicker: Bishoftu is nearly as absorption-rich per mass as Addis and shows no offset. Dark aerosol alone does not produce the discrepancy; whatever does is specific to Addis.</a:t>
+              <a:t>SAY: The grey cloud is every IMPROVE site, one dot per site median; the labeled dots are our sites on the same axis. Addis is the lowest value in either network, the suspect low-OC/EC signature, with Delhi and Beijing just above it. Adama, on the identical TOR basis as IMPROVE, sits at the middle of the pack: compositionally an ordinary site. Bishoftu cannot appear here yet because no OC of any kind has been measured for it.</a:t>
             </a:r>
           </a:p>
           <a:p/>
           <a:p>
             <a:r>
-              <a:t>NOTES: IMPROVE medians from local_db per site-day (TOR OC/EC in ng/m3 converted, fAbs Mm-1, grav PM2.5), sites with 100+ days only. SPARTAN points use the deployed FTIR OC/EC products and HIPS Fabs from the unified dataset; method mix (TOR vs FTIR OC) is labeled on the axis and is the standing caveat for panel one. Bishoftu appears only in the mass panel: it has Fabs and gravimetric mass but no OC yet; deployed OC/EC for ETBI awaits an analysis.Results pull on the VPN machine. Addis OC/EC and OC/fAbs being lowest is the June fig08 pair result, now reproduced with Bishoftu placed. Circularity note: SPARTAN OC/EC here are FTIR products, so the Addis OC/EC position partly reflects the calibration question itself; the mass panel is calibration-free.</a:t>
+              <a:t>NOTES: IMPROVE: per-site median of site-day TOR OC/EC, sites with 100+ days (n=199). SPARTAN cities use deployed FTIR OC/EC products, so their placement partly reflects the calibration question itself; Adama uses quartz TOR (n=5, July 2024), the same method as the IMPROVE axis. Bishoftu OC: no TOR on site, and deployed FTIR OC awaits an analysis.Results pull on the VPN machine.</a:t>
             </a:r>
           </a:p>
         </p:txBody>
@@ -658,13 +660,13 @@
           <a:lstStyle/>
           <a:p>
             <a:r>
-              <a:t>SAY: The two crossplots next to each other. Left: Addis, the deployed FTIR EC against HIPS on the fixed 190 filters; a tight line at 1.90x with an intercept of minus 4.2, the systematic disagreement this whole program is about. Right: Adama, the same production calibration against collocated quartz TOR; five filters scattering around the one-to-one line, median ratio 0.77, with no line fitted because five points cannot support one. Different reference method, and a completely different picture: a tight systematic line on the left, unstructured scatter on the right.</a:t>
+              <a:t>SAY: The same layout from the optical side: organic carbon per unit absorption. Addis again sits below every IMPROVE site, with Delhi and Beijing hugging the bottom edge and only Pasadena inside the pack. Together with the previous slide: the problem sites are absorption-rich relative to their organics. Neither Bishoftu nor Adama can join this axis yet; it needs OC and HIPS together.</a:t>
             </a:r>
           </a:p>
           <a:p/>
           <a:p>
             <a:r>
-              <a:t>NOTES: Axes differ by construction: Addis is ug/m3 against HIPS Fabs/10 (MAC 10); Adama is ug per filter against TOR ECTR, pairs matched by sample date (no HIPS exists for Adama PTFE, and no quartz exists at Addis; that asymmetry is the point of the quartz-TOR ask). The drawn Addis line is OLS, reproducing the committed ftir_17 number 1.90x-4.17; Deming at lambda-star reads steeper (2.24x-5.86) and both are in the stat box. Adama OLS on n=5 is descriptive only. The geometry comparison, line versus scatter, is the claim; the fit numbers are context.</a:t>
+              <a:t>NOTES: This is the June presentation's fig08 claim, rebuilt: Ann asked for exactly this pair, OC/EC then OC/fAbs, and predicted Addis would move from mid-pack to dead last; on these medians Addis is lowest on both. IMPROVE OC converted ng to ug; fAbs in 1/Mm. Bishoftu lacks OC; Adama lacks HIPS (quartz filters).</a:t>
             </a:r>
           </a:p>
         </p:txBody>
@@ -734,13 +736,13 @@
           <a:lstStyle/>
           <a:p>
             <a:r>
-              <a:t>SAY: The comparison Ann asked about, from the five co-located PTFE and quartz pairs. Left: FTIR EC over TOR EC per filter. The production calibration scatters around one with a median of 0.77; there is no systematic factor-of-two gap like the Addis crossplot, though five filters is five filters. The biomass-trained calibrations over-read by about one and a half times, which is a calibration-choice effect, not an Adama anomaly. Right: the thermal char-to-soot split. Every filter is soot-dominated; nothing here looks like a charcoal-heavy aerosol either.</a:t>
+              <a:t>SAY: The calibration-free axis, and the one Bishoftu can join today: absorption per unit PM mass. Beijing and Pasadena sit near the top of the IMPROVE pack, Delhi at its edge, and both Ethiopian sites are beyond every IMPROVE site: Bishoftu at 1.6, Addis at 2.2. The kicker: Bishoftu is nearly as dark per unit mass as Addis and shows no offset. Dark aerosol alone does not produce the discrepancy; whatever does is specific to Addis.</a:t>
             </a:r>
           </a:p>
           <a:p/>
           <a:p>
             <a:r>
-              <a:t>NOTES: Pairs matched by sample date (PTFE J1233-J1285 vs quartz J1675-J1703), July 2024 only, n=5. Ratios are unitless so the loading-vs-concentration units question drops out. char/soot = (EC1-OP)/(EC2+EC3), Han convention; all values 0.02 to 0.58, char-dominated would be above 1. Committed table: spartan_ec_2026_06_16/tables/adama_ec_calibration_comparison.csv.</a:t>
+              <a:t>NOTES: Bishoftu: batch Fabs over gravimetric mass concentration from the DB export (26 filters). SPARTAN cities: HIPS_Fabs over ChemSpec_Filter_PM2.5_mass (base-FilterId join). IMPROVE: fAbs over grav PM2.5 per site-day. No FTIR anywhere in this panel, so it is immune to the calibration circularity caveat. Adama has no PTFE optics, so no point exists for it here.</a:t>
             </a:r>
           </a:p>
         </p:txBody>
@@ -766,6 +768,158 @@
 </file>
 
 <file path=ppt/notesSlides/notesSlide5.xml><?xml version="1.0" encoding="utf-8"?>
+<p:notes xmlns:a="http://schemas.openxmlformats.org/drawingml/2006/main" xmlns:p="http://schemas.openxmlformats.org/presentationml/2006/main" xmlns:r="http://schemas.openxmlformats.org/officeDocument/2006/relationships">
+  <p:cSld>
+    <p:spTree>
+      <p:nvGrpSpPr>
+        <p:cNvPr id="1" name=""/>
+        <p:cNvGrpSpPr/>
+        <p:nvPr/>
+      </p:nvGrpSpPr>
+      <p:grpSpPr>
+        <a:xfrm>
+          <a:off x="0" y="0"/>
+          <a:ext cx="0" cy="0"/>
+          <a:chOff x="0" y="0"/>
+          <a:chExt cx="0" cy="0"/>
+        </a:xfrm>
+      </p:grpSpPr>
+      <p:sp>
+        <p:nvSpPr>
+          <p:cNvPr id="2" name="Slide Image Placeholder 1"/>
+          <p:cNvSpPr>
+            <a:spLocks noGrp="1"/>
+          </p:cNvSpPr>
+          <p:nvPr>
+            <p:ph type="sldImg" idx="2"/>
+          </p:nvPr>
+        </p:nvSpPr>
+        <p:spPr/>
+      </p:sp>
+      <p:sp>
+        <p:nvSpPr>
+          <p:cNvPr id="3" name="Notes Placeholder 2"/>
+          <p:cNvSpPr>
+            <a:spLocks noGrp="1"/>
+          </p:cNvSpPr>
+          <p:nvPr>
+            <p:ph type="body" idx="3" sz="quarter"/>
+          </p:nvPr>
+        </p:nvSpPr>
+        <p:spPr/>
+        <p:txBody>
+          <a:bodyPr/>
+          <a:lstStyle/>
+          <a:p>
+            <a:r>
+              <a:t>SAY: The two crossplots next to each other. Left: Addis, the deployed FTIR EC against HIPS on the fixed 190 filters; a tight line at 1.90x with an intercept of minus 4.2, the systematic disagreement this whole program is about. Right: Adama, the same production calibration against collocated quartz TOR; five filters scattering around the one-to-one line, median ratio 0.77, with no line fitted because five points cannot support one. Different reference method, and a completely different picture: a tight systematic line on the left, unstructured scatter on the right.</a:t>
+            </a:r>
+          </a:p>
+          <a:p/>
+          <a:p>
+            <a:r>
+              <a:t>NOTES: Axes differ by construction: Addis is ug/m3 against HIPS Fabs/10 (MAC 10); Adama is ug per filter against TOR ECTR, pairs matched by sample date (no HIPS exists for Adama PTFE, and no quartz exists at Addis; that asymmetry is the point of the quartz-TOR ask). The drawn Addis line is OLS, reproducing the committed ftir_17 number 1.90x-4.17; Deming at lambda-star reads steeper (2.24x-5.86) and both are in the stat box. Adama OLS on n=5 is descriptive only. The geometry comparison, line versus scatter, is the claim; the fit numbers are context.</a:t>
+            </a:r>
+          </a:p>
+        </p:txBody>
+      </p:sp>
+      <p:sp>
+        <p:nvSpPr>
+          <p:cNvPr id="4" name="Slide Number Placeholder 3"/>
+          <p:cNvSpPr>
+            <a:spLocks noGrp="1"/>
+          </p:cNvSpPr>
+          <p:nvPr>
+            <p:ph type="sldNum" idx="5" sz="quarter"/>
+          </p:nvPr>
+        </p:nvSpPr>
+        <p:spPr/>
+      </p:sp>
+    </p:spTree>
+  </p:cSld>
+  <p:clrMapOvr>
+    <a:masterClrMapping/>
+  </p:clrMapOvr>
+</p:notes>
+</file>
+
+<file path=ppt/notesSlides/notesSlide6.xml><?xml version="1.0" encoding="utf-8"?>
+<p:notes xmlns:a="http://schemas.openxmlformats.org/drawingml/2006/main" xmlns:p="http://schemas.openxmlformats.org/presentationml/2006/main" xmlns:r="http://schemas.openxmlformats.org/officeDocument/2006/relationships">
+  <p:cSld>
+    <p:spTree>
+      <p:nvGrpSpPr>
+        <p:cNvPr id="1" name=""/>
+        <p:cNvGrpSpPr/>
+        <p:nvPr/>
+      </p:nvGrpSpPr>
+      <p:grpSpPr>
+        <a:xfrm>
+          <a:off x="0" y="0"/>
+          <a:ext cx="0" cy="0"/>
+          <a:chOff x="0" y="0"/>
+          <a:chExt cx="0" cy="0"/>
+        </a:xfrm>
+      </p:grpSpPr>
+      <p:sp>
+        <p:nvSpPr>
+          <p:cNvPr id="2" name="Slide Image Placeholder 1"/>
+          <p:cNvSpPr>
+            <a:spLocks noGrp="1"/>
+          </p:cNvSpPr>
+          <p:nvPr>
+            <p:ph type="sldImg" idx="2"/>
+          </p:nvPr>
+        </p:nvSpPr>
+        <p:spPr/>
+      </p:sp>
+      <p:sp>
+        <p:nvSpPr>
+          <p:cNvPr id="3" name="Notes Placeholder 2"/>
+          <p:cNvSpPr>
+            <a:spLocks noGrp="1"/>
+          </p:cNvSpPr>
+          <p:nvPr>
+            <p:ph type="body" idx="3" sz="quarter"/>
+          </p:nvPr>
+        </p:nvSpPr>
+        <p:spPr/>
+        <p:txBody>
+          <a:bodyPr/>
+          <a:lstStyle/>
+          <a:p>
+            <a:r>
+              <a:t>SAY: The comparison Ann asked about, from the five co-located PTFE and quartz pairs. Left: FTIR EC over TOR EC per filter. The production calibration scatters around one with a median of 0.77; there is no systematic factor-of-two gap like the Addis crossplot, though five filters is five filters. The biomass-trained calibrations over-read by about one and a half times, which is a calibration-choice effect, not an Adama anomaly. Right: the thermal char-to-soot split. Every filter is soot-dominated; nothing here looks like a charcoal-heavy aerosol either.</a:t>
+            </a:r>
+          </a:p>
+          <a:p/>
+          <a:p>
+            <a:r>
+              <a:t>NOTES: Pairs matched by sample date (PTFE J1233-J1285 vs quartz J1675-J1703), July 2024 only, n=5. Ratios are unitless so the loading-vs-concentration units question drops out. char/soot = (EC1-OP)/(EC2+EC3), Han convention; all values 0.02 to 0.58, char-dominated would be above 1. Committed table: spartan_ec_2026_06_16/tables/adama_ec_calibration_comparison.csv.</a:t>
+            </a:r>
+          </a:p>
+        </p:txBody>
+      </p:sp>
+      <p:sp>
+        <p:nvSpPr>
+          <p:cNvPr id="4" name="Slide Number Placeholder 3"/>
+          <p:cNvSpPr>
+            <a:spLocks noGrp="1"/>
+          </p:cNvSpPr>
+          <p:nvPr>
+            <p:ph type="sldNum" idx="5" sz="quarter"/>
+          </p:nvPr>
+        </p:nvSpPr>
+        <p:spPr/>
+      </p:sp>
+    </p:spTree>
+  </p:cSld>
+  <p:clrMapOvr>
+    <a:masterClrMapping/>
+  </p:clrMapOvr>
+</p:notes>
+</file>
+
+<file path=ppt/notesSlides/notesSlide7.xml><?xml version="1.0" encoding="utf-8"?>
 <p:notes xmlns:a="http://schemas.openxmlformats.org/drawingml/2006/main" xmlns:p="http://schemas.openxmlformats.org/presentationml/2006/main" xmlns:r="http://schemas.openxmlformats.org/officeDocument/2006/relationships">
   <p:cSld>
     <p:spTree>
@@ -3929,14 +4083,14 @@
               </a:defRPr>
             </a:pPr>
             <a:r>
-              <a:t>Both Ethiopian sites are absorption-rich beyond all of IMPROVE, yet only Addis has the offset</a:t>
+              <a:t>OC / EC across 199 IMPROVE sites: Addis is the lowest anywhere; Adama sits at the median</a:t>
             </a:r>
           </a:p>
         </p:txBody>
       </p:sp>
       <p:pic>
         <p:nvPicPr>
-          <p:cNvPr id="3" name="Picture 2" descr="f_sites_context_ratios.png"/>
+          <p:cNvPr id="3" name="Picture 2" descr="f_ratio_oc_ec.png"/>
           <p:cNvPicPr>
             <a:picLocks noChangeAspect="1"/>
           </p:cNvPicPr>
@@ -3950,8 +4104,8 @@
         </p:blipFill>
         <p:spPr>
           <a:xfrm>
-            <a:off x="518007" y="1774007"/>
-            <a:ext cx="11155680" cy="4132945"/>
+            <a:off x="518007" y="2233305"/>
+            <a:ext cx="11155680" cy="3214348"/>
           </a:xfrm>
           <a:prstGeom prst="rect">
             <a:avLst/>
@@ -3967,6 +4121,160 @@
 </file>
 
 <file path=ppt/slides/slide3.xml><?xml version="1.0" encoding="utf-8"?>
+<p:sld xmlns:a="http://schemas.openxmlformats.org/drawingml/2006/main" xmlns:p="http://schemas.openxmlformats.org/presentationml/2006/main" xmlns:r="http://schemas.openxmlformats.org/officeDocument/2006/relationships">
+  <p:cSld>
+    <p:spTree>
+      <p:nvGrpSpPr>
+        <p:cNvPr id="1" name=""/>
+        <p:cNvGrpSpPr/>
+        <p:nvPr/>
+      </p:nvGrpSpPr>
+      <p:grpSpPr/>
+      <p:sp>
+        <p:nvSpPr>
+          <p:cNvPr id="2" name="TextBox 1"/>
+          <p:cNvSpPr txBox="1"/>
+          <p:nvPr/>
+        </p:nvSpPr>
+        <p:spPr>
+          <a:xfrm>
+            <a:off x="411480" y="201168"/>
+            <a:ext cx="11430000" cy="868680"/>
+          </a:xfrm>
+          <a:prstGeom prst="rect">
+            <a:avLst/>
+          </a:prstGeom>
+          <a:noFill/>
+        </p:spPr>
+        <p:txBody>
+          <a:bodyPr wrap="square">
+            <a:spAutoFit/>
+          </a:bodyPr>
+          <a:lstStyle/>
+          <a:p>
+            <a:pPr>
+              <a:defRPr sz="2000" b="1">
+                <a:solidFill>
+                  <a:srgbClr val="22252A"/>
+                </a:solidFill>
+              </a:defRPr>
+            </a:pPr>
+            <a:r>
+              <a:t>OC / fAbs: Addis has the least organic carbon per unit absorption of any site in either network</a:t>
+            </a:r>
+          </a:p>
+        </p:txBody>
+      </p:sp>
+      <p:pic>
+        <p:nvPicPr>
+          <p:cNvPr id="3" name="Picture 2" descr="f_ratio_oc_fabs.png"/>
+          <p:cNvPicPr>
+            <a:picLocks noChangeAspect="1"/>
+          </p:cNvPicPr>
+          <p:nvPr/>
+        </p:nvPicPr>
+        <p:blipFill>
+          <a:blip r:embed="rId2"/>
+          <a:stretch>
+            <a:fillRect/>
+          </a:stretch>
+        </p:blipFill>
+        <p:spPr>
+          <a:xfrm>
+            <a:off x="518007" y="2233305"/>
+            <a:ext cx="11155680" cy="3214348"/>
+          </a:xfrm>
+          <a:prstGeom prst="rect">
+            <a:avLst/>
+          </a:prstGeom>
+        </p:spPr>
+      </p:pic>
+    </p:spTree>
+  </p:cSld>
+  <p:clrMapOvr>
+    <a:masterClrMapping/>
+  </p:clrMapOvr>
+</p:sld>
+</file>
+
+<file path=ppt/slides/slide4.xml><?xml version="1.0" encoding="utf-8"?>
+<p:sld xmlns:a="http://schemas.openxmlformats.org/drawingml/2006/main" xmlns:p="http://schemas.openxmlformats.org/presentationml/2006/main" xmlns:r="http://schemas.openxmlformats.org/officeDocument/2006/relationships">
+  <p:cSld>
+    <p:spTree>
+      <p:nvGrpSpPr>
+        <p:cNvPr id="1" name=""/>
+        <p:cNvGrpSpPr/>
+        <p:nvPr/>
+      </p:nvGrpSpPr>
+      <p:grpSpPr/>
+      <p:sp>
+        <p:nvSpPr>
+          <p:cNvPr id="2" name="TextBox 1"/>
+          <p:cNvSpPr txBox="1"/>
+          <p:nvPr/>
+        </p:nvSpPr>
+        <p:spPr>
+          <a:xfrm>
+            <a:off x="411480" y="201168"/>
+            <a:ext cx="11430000" cy="868680"/>
+          </a:xfrm>
+          <a:prstGeom prst="rect">
+            <a:avLst/>
+          </a:prstGeom>
+          <a:noFill/>
+        </p:spPr>
+        <p:txBody>
+          <a:bodyPr wrap="square">
+            <a:spAutoFit/>
+          </a:bodyPr>
+          <a:lstStyle/>
+          <a:p>
+            <a:pPr>
+              <a:defRPr sz="2000" b="1">
+                <a:solidFill>
+                  <a:srgbClr val="22252A"/>
+                </a:solidFill>
+              </a:defRPr>
+            </a:pPr>
+            <a:r>
+              <a:t>Absorption per unit mass: both Ethiopian sites exceed every IMPROVE site, yet only Addis has the offset</a:t>
+            </a:r>
+          </a:p>
+        </p:txBody>
+      </p:sp>
+      <p:pic>
+        <p:nvPicPr>
+          <p:cNvPr id="3" name="Picture 2" descr="f_ratio_fabs_pm.png"/>
+          <p:cNvPicPr>
+            <a:picLocks noChangeAspect="1"/>
+          </p:cNvPicPr>
+          <p:nvPr/>
+        </p:nvPicPr>
+        <p:blipFill>
+          <a:blip r:embed="rId2"/>
+          <a:stretch>
+            <a:fillRect/>
+          </a:stretch>
+        </p:blipFill>
+        <p:spPr>
+          <a:xfrm>
+            <a:off x="518007" y="2233305"/>
+            <a:ext cx="11155680" cy="3214348"/>
+          </a:xfrm>
+          <a:prstGeom prst="rect">
+            <a:avLst/>
+          </a:prstGeom>
+        </p:spPr>
+      </p:pic>
+    </p:spTree>
+  </p:cSld>
+  <p:clrMapOvr>
+    <a:masterClrMapping/>
+  </p:clrMapOvr>
+</p:sld>
+</file>
+
+<file path=ppt/slides/slide5.xml><?xml version="1.0" encoding="utf-8"?>
 <p:sld xmlns:a="http://schemas.openxmlformats.org/drawingml/2006/main" xmlns:p="http://schemas.openxmlformats.org/presentationml/2006/main" xmlns:r="http://schemas.openxmlformats.org/officeDocument/2006/relationships">
   <p:cSld>
     <p:spTree>
@@ -4043,7 +4351,7 @@
 </p:sld>
 </file>
 
-<file path=ppt/slides/slide4.xml><?xml version="1.0" encoding="utf-8"?>
+<file path=ppt/slides/slide6.xml><?xml version="1.0" encoding="utf-8"?>
 <p:sld xmlns:a="http://schemas.openxmlformats.org/drawingml/2006/main" xmlns:p="http://schemas.openxmlformats.org/presentationml/2006/main" xmlns:r="http://schemas.openxmlformats.org/officeDocument/2006/relationships">
   <p:cSld>
     <p:spTree>
@@ -4120,7 +4428,7 @@
 </p:sld>
 </file>
 
-<file path=ppt/slides/slide5.xml><?xml version="1.0" encoding="utf-8"?>
+<file path=ppt/slides/slide7.xml><?xml version="1.0" encoding="utf-8"?>
 <p:sld xmlns:a="http://schemas.openxmlformats.org/drawingml/2006/main" xmlns:p="http://schemas.openxmlformats.org/presentationml/2006/main" xmlns:r="http://schemas.openxmlformats.org/officeDocument/2006/relationships">
   <p:cSld>
     <p:spTree>

</xml_diff>